<commit_message>
Team credit + refreshed deck
- In-file author credit -> 'Adam, Anand & Ugo' across src/*.py and README
  (git commit authorship unchanged).
- Regenerate slide deck: Content Recapper name, general tagline, input box says
  'file' not 'paste', takeaways say 'upload a file', byline + notes use real
  speaker names (Adam / Ugo / Anand).
- Gitignore Office ~$ lock files.
</commit_message>
<xml_diff>
--- a/Podcast-Studio-Presentation.pptx
+++ b/Podcast-Studio-Presentation.pptx
@@ -507,7 +507,7 @@
           <a:p>
             <a:r>
               <a:rPr lang="en-US" dirty="0"/>
-              <a:t>Title. SPEAKER 1 opens: name the team and what we built in one line.</a:t>
+              <a:t>Title. Adam opens: name the team and what we built in one line.</a:t>
             </a:r>
             <a:endParaRPr lang="en-US" dirty="0"/>
           </a:p>
@@ -595,7 +595,7 @@
           <a:p>
             <a:r>
               <a:rPr lang="en-US" dirty="0"/>
-              <a:t>SPEAKER 1 — Problem. Anchor it in a real audience; hand off to SPEAKER 2 for the live demo.</a:t>
+              <a:t>Adam — Problem. Anchor it in a real audience; hand off to Ugo for the live demo.</a:t>
             </a:r>
             <a:endParaRPr lang="en-US" dirty="0"/>
           </a:p>
@@ -683,7 +683,7 @@
           <a:p>
             <a:r>
               <a:rPr lang="en-US" dirty="0"/>
-              <a:t>Shown while SPEAKER 2 demos / SPEAKER 3 explains. Call out 2-3 technical choices — data structures answers a graded criterion.</a:t>
+              <a:t>Shown while Ugo demos / Anand explains. Call out 2-3 technical choices — data structures answers a graded criterion.</a:t>
             </a:r>
             <a:endParaRPr lang="en-US" dirty="0"/>
           </a:p>
@@ -771,7 +771,7 @@
           <a:p>
             <a:r>
               <a:rPr lang="en-US" dirty="0"/>
-              <a:t>SPEAKER 2 — Live demo (~3.5 min). Keep to pick-a-saved-lesson. If Wi-Fi/API stalls, play a pre-generated mp3 from output/ and keep talking.</a:t>
+              <a:t>Ugo — Live demo (~3.5 min). Keep to pick-a-saved-lesson. If Wi-Fi/API stalls, play a pre-generated mp3 from output/ and keep talking.</a:t>
             </a:r>
             <a:endParaRPr lang="en-US" dirty="0"/>
           </a:p>
@@ -859,7 +859,7 @@
           <a:p>
             <a:r>
               <a:rPr lang="en-US" dirty="0"/>
-              <a:t>SPEAKER 3 — Takeaways + technical choices + what's next (~1.5 min), then hand to Q&amp;A.</a:t>
+              <a:t>Anand — Takeaways + technical choices + what's next (~1.5 min), then hand to Q&amp;A.</a:t>
             </a:r>
             <a:endParaRPr lang="en-US" dirty="0"/>
           </a:p>
@@ -947,7 +947,7 @@
           <a:p>
             <a:r>
               <a:rPr lang="en-US" dirty="0"/>
-              <a:t>All three field Q&amp;A. SPEAKER 1: audience/use. SPEAKER 2: demo/product/cost. SPEAKER 3: technical.</a:t>
+              <a:t>All three field Q&amp;A. Adam: audience/use. Ugo: demo/product/cost. Anand: technical.</a:t>
             </a:r>
             <a:endParaRPr lang="en-US" dirty="0"/>
           </a:p>
@@ -1671,7 +1671,7 @@
                 <a:ea typeface="Cambria" pitchFamily="34" charset="-122"/>
                 <a:cs typeface="Cambria" pitchFamily="34" charset="-120"/>
               </a:rPr>
-              <a:t>Daily Lesson Recapper</a:t>
+              <a:t>Content Recapper</a:t>
             </a:r>
             <a:endParaRPr lang="en-US" sz="2800" dirty="0"/>
           </a:p>
@@ -1710,7 +1710,7 @@
                 <a:ea typeface="Calibri" pitchFamily="34" charset="-122"/>
                 <a:cs typeface="Calibri" pitchFamily="34" charset="-120"/>
               </a:rPr>
-              <a:t>Turn any lesson into a one-minute spoken recap.</a:t>
+              <a:t>Turn any lesson, article, or report into a short spoken recap.</a:t>
             </a:r>
             <a:endParaRPr lang="en-US" sz="1800" dirty="0"/>
           </a:p>
@@ -1749,7 +1749,7 @@
                 <a:ea typeface="Calibri" pitchFamily="34" charset="-122"/>
                 <a:cs typeface="Calibri" pitchFamily="34" charset="-120"/>
               </a:rPr>
-              <a:t>SPEAKER 1   ·   SPEAKER 2   ·   SPEAKER 3</a:t>
+              <a:t>ADAM   ·   UGO   ·   ANAND</a:t>
             </a:r>
             <a:endParaRPr lang="en-US" sz="1400" dirty="0"/>
           </a:p>
@@ -2538,7 +2538,7 @@
                 <a:ea typeface="Calibri" pitchFamily="34" charset="-122"/>
                 <a:cs typeface="Calibri" pitchFamily="34" charset="-120"/>
               </a:rPr>
-              <a:t>URL, or paste</a:t>
+              <a:t>URL, or file</a:t>
             </a:r>
             <a:endParaRPr lang="en-US" sz="1250" dirty="0"/>
           </a:p>
@@ -4395,7 +4395,7 @@
                 <a:ea typeface="Calibri" pitchFamily="34" charset="-122"/>
                 <a:cs typeface="Calibri" pitchFamily="34" charset="-120"/>
               </a:rPr>
-              <a:t>Flexible inputs: pick a lesson, fetch a URL, or paste text.</a:t>
+              <a:t>Flexible inputs: pick a lesson, fetch a URL, or upload a file.</a:t>
             </a:r>
             <a:endParaRPr lang="en-US" sz="1550" dirty="0"/>
           </a:p>

</xml_diff>

<commit_message>
Update Podcast presentation file with recent changes
</commit_message>
<xml_diff>
--- a/Podcast-Studio-Presentation.pptx
+++ b/Podcast-Studio-Presentation.pptx
@@ -5148,13 +5148,15 @@
               </a:rPr>
               <a:t>Choose-the-length of podcast (1m /3m)</a:t>
             </a:r>
-            <a:endParaRPr lang="en-US" sz="1550" dirty="0"/>
           </a:p>
           <a:p>
             <a:pPr marL="190500" indent="-190500">
               <a:lnSpc>
                 <a:spcPct val="105000"/>
               </a:lnSpc>
+              <a:spcAft>
+                <a:spcPts val="1200"/>
+              </a:spcAft>
               <a:buSzPct val="100000"/>
               <a:buChar char="•"/>
             </a:pPr>
@@ -5164,10 +5166,9 @@
                   <a:srgbClr val="FFFFFF"/>
                 </a:solidFill>
                 <a:latin typeface="Calibri" pitchFamily="34" charset="0"/>
-                <a:ea typeface="Calibri" pitchFamily="34" charset="-122"/>
                 <a:cs typeface="Calibri" pitchFamily="34" charset="-120"/>
               </a:rPr>
-              <a:t>Deploy online so anyone can use it</a:t>
+              <a:t>Deploy as public utility</a:t>
             </a:r>
             <a:endParaRPr lang="en-US" sz="1550" dirty="0"/>
           </a:p>

</xml_diff>

<commit_message>
Update Podcast presentation file with new content
</commit_message>
<xml_diff>
--- a/Podcast-Studio-Presentation.pptx
+++ b/Podcast-Studio-Presentation.pptx
@@ -463,6 +463,745 @@
             <a:r>
               <a:rPr lang="en-US" dirty="0"/>
               <a:t>SPEAKER 2 — Live demo (~3.5 min). Keep to pick-a-saved-lesson. If Wi-Fi/API stalls, play a pre-generated mp3 from output/ and keep talking.</a:t>
+            </a:r>
+          </a:p>
+          <a:p>
+            <a:endParaRPr lang="en-US" dirty="0"/>
+          </a:p>
+          <a:p>
+            <a:r>
+              <a:rPr lang="en-US" sz="1200" b="1" i="0" kern="1200" dirty="0">
+                <a:solidFill>
+                  <a:schemeClr val="tx1"/>
+                </a:solidFill>
+                <a:effectLst/>
+                <a:latin typeface="+mn-lt"/>
+                <a:ea typeface="+mn-ea"/>
+                <a:cs typeface="+mn-cs"/>
+              </a:rPr>
+              <a:t>Before you start:</a:t>
+            </a:r>
+            <a:r>
+              <a:rPr lang="en-US" sz="1200" b="0" i="0" kern="1200" dirty="0">
+                <a:solidFill>
+                  <a:schemeClr val="tx1"/>
+                </a:solidFill>
+                <a:effectLst/>
+                <a:latin typeface="+mn-lt"/>
+                <a:ea typeface="+mn-ea"/>
+                <a:cs typeface="+mn-cs"/>
+              </a:rPr>
+              <a:t> app already open at </a:t>
+            </a:r>
+            <a:r>
+              <a:rPr lang="en-US" sz="1020" b="0" i="0" kern="1200" dirty="0">
+                <a:solidFill>
+                  <a:schemeClr val="tx1"/>
+                </a:solidFill>
+                <a:effectLst/>
+                <a:latin typeface="+mn-lt"/>
+                <a:ea typeface="+mn-ea"/>
+                <a:cs typeface="+mn-cs"/>
+              </a:rPr>
+              <a:t>http://localhost:7860</a:t>
+            </a:r>
+            <a:r>
+              <a:rPr lang="en-US" sz="1200" b="0" i="0" kern="1200" dirty="0">
+                <a:solidFill>
+                  <a:schemeClr val="tx1"/>
+                </a:solidFill>
+                <a:effectLst/>
+                <a:latin typeface="+mn-lt"/>
+                <a:ea typeface="+mn-ea"/>
+                <a:cs typeface="+mn-cs"/>
+              </a:rPr>
+              <a:t>, Wi-Fi checked, a backup </a:t>
+            </a:r>
+            <a:r>
+              <a:rPr lang="en-US" sz="1020" b="0" i="0" kern="1200" dirty="0">
+                <a:solidFill>
+                  <a:schemeClr val="tx1"/>
+                </a:solidFill>
+                <a:effectLst/>
+                <a:latin typeface="+mn-lt"/>
+                <a:ea typeface="+mn-ea"/>
+                <a:cs typeface="+mn-cs"/>
+              </a:rPr>
+              <a:t>.mp3</a:t>
+            </a:r>
+            <a:r>
+              <a:rPr lang="en-US" sz="1200" b="0" i="0" kern="1200" dirty="0">
+                <a:solidFill>
+                  <a:schemeClr val="tx1"/>
+                </a:solidFill>
+                <a:effectLst/>
+                <a:latin typeface="+mn-lt"/>
+                <a:ea typeface="+mn-ea"/>
+                <a:cs typeface="+mn-cs"/>
+              </a:rPr>
+              <a:t> ready.</a:t>
+            </a:r>
+          </a:p>
+          <a:p>
+            <a:endParaRPr lang="en-US" sz="1200" b="1" i="0" kern="1200" dirty="0">
+              <a:solidFill>
+                <a:schemeClr val="tx1"/>
+              </a:solidFill>
+              <a:effectLst/>
+              <a:latin typeface="+mn-lt"/>
+              <a:ea typeface="+mn-ea"/>
+              <a:cs typeface="+mn-cs"/>
+            </a:endParaRPr>
+          </a:p>
+          <a:p>
+            <a:r>
+              <a:rPr lang="en-US" sz="1200" b="0" i="0" kern="1200" dirty="0">
+                <a:solidFill>
+                  <a:schemeClr val="tx1"/>
+                </a:solidFill>
+                <a:effectLst/>
+                <a:latin typeface="+mn-lt"/>
+                <a:ea typeface="+mn-ea"/>
+                <a:cs typeface="+mn-cs"/>
+              </a:rPr>
+              <a:t>“This is the Content Recapper app. On the left I </a:t>
+            </a:r>
+            <a:r>
+              <a:rPr lang="en-US" sz="1200" b="1" i="0" kern="1200" dirty="0">
+                <a:solidFill>
+                  <a:schemeClr val="tx1"/>
+                </a:solidFill>
+                <a:effectLst/>
+                <a:latin typeface="+mn-lt"/>
+                <a:ea typeface="+mn-ea"/>
+                <a:cs typeface="+mn-cs"/>
+              </a:rPr>
+              <a:t>pick a saved lesson</a:t>
+            </a:r>
+            <a:r>
+              <a:rPr lang="en-US" sz="1200" b="0" i="0" kern="1200" dirty="0">
+                <a:solidFill>
+                  <a:schemeClr val="tx1"/>
+                </a:solidFill>
+                <a:effectLst/>
+                <a:latin typeface="+mn-lt"/>
+                <a:ea typeface="+mn-ea"/>
+                <a:cs typeface="+mn-cs"/>
+              </a:rPr>
+              <a:t>, provide a public non-password-gated </a:t>
+            </a:r>
+            <a:r>
+              <a:rPr lang="en-US" sz="1200" b="0" i="0" kern="1200" dirty="0" err="1">
+                <a:solidFill>
+                  <a:schemeClr val="tx1"/>
+                </a:solidFill>
+                <a:effectLst/>
+                <a:latin typeface="+mn-lt"/>
+                <a:ea typeface="+mn-ea"/>
+                <a:cs typeface="+mn-cs"/>
+              </a:rPr>
+              <a:t>url</a:t>
+            </a:r>
+            <a:r>
+              <a:rPr lang="en-US" sz="1200" b="0" i="0" kern="1200" dirty="0">
+                <a:solidFill>
+                  <a:schemeClr val="tx1"/>
+                </a:solidFill>
+                <a:effectLst/>
+                <a:latin typeface="+mn-lt"/>
+                <a:ea typeface="+mn-ea"/>
+                <a:cs typeface="+mn-cs"/>
+              </a:rPr>
+              <a:t> or upload a compatible input file format”</a:t>
+            </a:r>
+          </a:p>
+          <a:p>
+            <a:endParaRPr lang="en-US" sz="1200" b="0" i="0" kern="1200" dirty="0">
+              <a:solidFill>
+                <a:schemeClr val="tx1"/>
+              </a:solidFill>
+              <a:effectLst/>
+              <a:latin typeface="+mn-lt"/>
+              <a:ea typeface="+mn-ea"/>
+              <a:cs typeface="+mn-cs"/>
+            </a:endParaRPr>
+          </a:p>
+          <a:p>
+            <a:r>
+              <a:rPr lang="en-US" sz="1200" b="0" i="0" kern="1200" dirty="0">
+                <a:solidFill>
+                  <a:schemeClr val="tx1"/>
+                </a:solidFill>
+                <a:effectLst/>
+                <a:latin typeface="+mn-lt"/>
+                <a:ea typeface="+mn-ea"/>
+                <a:cs typeface="+mn-cs"/>
+              </a:rPr>
+              <a:t>Click </a:t>
+            </a:r>
+            <a:r>
+              <a:rPr lang="en-US" sz="1200" b="1" i="0" kern="1200" dirty="0">
+                <a:solidFill>
+                  <a:schemeClr val="tx1"/>
+                </a:solidFill>
+                <a:effectLst/>
+                <a:latin typeface="+mn-lt"/>
+                <a:ea typeface="+mn-ea"/>
+                <a:cs typeface="+mn-cs"/>
+              </a:rPr>
+              <a:t>Generate recap podcast</a:t>
+            </a:r>
+            <a:r>
+              <a:rPr lang="en-US" sz="1200" b="0" i="0" kern="1200" dirty="0">
+                <a:solidFill>
+                  <a:schemeClr val="tx1"/>
+                </a:solidFill>
+                <a:effectLst/>
+                <a:latin typeface="+mn-lt"/>
+                <a:ea typeface="+mn-ea"/>
+                <a:cs typeface="+mn-cs"/>
+              </a:rPr>
+              <a:t>.</a:t>
+            </a:r>
+          </a:p>
+          <a:p>
+            <a:endParaRPr lang="en-US" sz="1200" b="0" i="0" kern="1200" dirty="0">
+              <a:solidFill>
+                <a:schemeClr val="tx1"/>
+              </a:solidFill>
+              <a:effectLst/>
+              <a:latin typeface="+mn-lt"/>
+              <a:ea typeface="+mn-ea"/>
+              <a:cs typeface="+mn-cs"/>
+            </a:endParaRPr>
+          </a:p>
+          <a:p>
+            <a:r>
+              <a:rPr lang="en-US" sz="1200" b="0" i="0" kern="1200" dirty="0">
+                <a:solidFill>
+                  <a:schemeClr val="tx1"/>
+                </a:solidFill>
+                <a:effectLst/>
+                <a:latin typeface="+mn-lt"/>
+                <a:ea typeface="+mn-ea"/>
+                <a:cs typeface="+mn-cs"/>
+              </a:rPr>
+              <a:t>As it runs, narrate </a:t>
+            </a:r>
+            <a:r>
+              <a:rPr lang="en-US" sz="1200" b="1" i="0" kern="1200" dirty="0">
+                <a:solidFill>
+                  <a:schemeClr val="tx1"/>
+                </a:solidFill>
+                <a:effectLst/>
+                <a:latin typeface="+mn-lt"/>
+                <a:ea typeface="+mn-ea"/>
+                <a:cs typeface="+mn-cs"/>
+              </a:rPr>
+              <a:t>one or two technical choices</a:t>
+            </a:r>
+            <a:r>
+              <a:rPr lang="en-US" sz="1200" b="0" i="0" kern="1200" dirty="0">
+                <a:solidFill>
+                  <a:schemeClr val="tx1"/>
+                </a:solidFill>
+                <a:effectLst/>
+                <a:latin typeface="+mn-lt"/>
+                <a:ea typeface="+mn-ea"/>
+                <a:cs typeface="+mn-cs"/>
+              </a:rPr>
+              <a:t> </a:t>
+            </a:r>
+            <a:r>
+              <a:rPr lang="en-US" sz="1200" b="0" i="1" kern="1200" dirty="0">
+                <a:solidFill>
+                  <a:schemeClr val="tx1"/>
+                </a:solidFill>
+                <a:effectLst/>
+                <a:latin typeface="+mn-lt"/>
+                <a:ea typeface="+mn-ea"/>
+                <a:cs typeface="+mn-cs"/>
+              </a:rPr>
+              <a:t>(this is graded)</a:t>
+            </a:r>
+            <a:r>
+              <a:rPr lang="en-US" sz="1200" b="0" i="0" kern="1200" dirty="0">
+                <a:solidFill>
+                  <a:schemeClr val="tx1"/>
+                </a:solidFill>
+                <a:effectLst/>
+                <a:latin typeface="+mn-lt"/>
+                <a:ea typeface="+mn-ea"/>
+                <a:cs typeface="+mn-cs"/>
+              </a:rPr>
+              <a:t>:</a:t>
+            </a:r>
+          </a:p>
+          <a:p>
+            <a:pPr lvl="1"/>
+            <a:r>
+              <a:rPr lang="en-US" sz="1200" b="0" i="0" kern="1200" dirty="0">
+                <a:solidFill>
+                  <a:schemeClr val="tx1"/>
+                </a:solidFill>
+                <a:effectLst/>
+                <a:latin typeface="+mn-lt"/>
+                <a:ea typeface="+mn-ea"/>
+                <a:cs typeface="+mn-cs"/>
+              </a:rPr>
+              <a:t>"The lesson text goes to an </a:t>
+            </a:r>
+            <a:r>
+              <a:rPr lang="en-US" sz="1200" b="1" i="0" kern="1200" dirty="0">
+                <a:solidFill>
+                  <a:schemeClr val="tx1"/>
+                </a:solidFill>
+                <a:effectLst/>
+                <a:latin typeface="+mn-lt"/>
+                <a:ea typeface="+mn-ea"/>
+                <a:cs typeface="+mn-cs"/>
+              </a:rPr>
+              <a:t>LLM that returns a structured result</a:t>
+            </a:r>
+            <a:r>
+              <a:rPr lang="en-US" sz="1200" b="0" i="0" kern="1200" dirty="0">
+                <a:solidFill>
+                  <a:schemeClr val="tx1"/>
+                </a:solidFill>
+                <a:effectLst/>
+                <a:latin typeface="+mn-lt"/>
+                <a:ea typeface="+mn-ea"/>
+                <a:cs typeface="+mn-cs"/>
+              </a:rPr>
+              <a:t> — title, key points, and a spoken script — using a </a:t>
+            </a:r>
+            <a:r>
+              <a:rPr lang="en-US" sz="1200" b="1" i="0" kern="1200" dirty="0">
+                <a:solidFill>
+                  <a:schemeClr val="tx1"/>
+                </a:solidFill>
+                <a:effectLst/>
+                <a:latin typeface="+mn-lt"/>
+                <a:ea typeface="+mn-ea"/>
+                <a:cs typeface="+mn-cs"/>
+              </a:rPr>
+              <a:t>schema</a:t>
+            </a:r>
+            <a:r>
+              <a:rPr lang="en-US" sz="1200" b="0" i="0" kern="1200" dirty="0">
+                <a:solidFill>
+                  <a:schemeClr val="tx1"/>
+                </a:solidFill>
+                <a:effectLst/>
+                <a:latin typeface="+mn-lt"/>
+                <a:ea typeface="+mn-ea"/>
+                <a:cs typeface="+mn-cs"/>
+              </a:rPr>
+              <a:t>, so the output is always the right shape and can't drift into broken formatting."</a:t>
+            </a:r>
+          </a:p>
+          <a:p>
+            <a:pPr lvl="1"/>
+            <a:r>
+              <a:rPr lang="en-US" sz="1200" b="0" i="0" kern="1200" dirty="0">
+                <a:solidFill>
+                  <a:schemeClr val="tx1"/>
+                </a:solidFill>
+                <a:effectLst/>
+                <a:latin typeface="+mn-lt"/>
+                <a:ea typeface="+mn-ea"/>
+                <a:cs typeface="+mn-cs"/>
+              </a:rPr>
+              <a:t>"Then </a:t>
+            </a:r>
+            <a:r>
+              <a:rPr lang="en-US" sz="1200" b="1" i="0" kern="1200" dirty="0">
+                <a:solidFill>
+                  <a:schemeClr val="tx1"/>
+                </a:solidFill>
+                <a:effectLst/>
+                <a:latin typeface="+mn-lt"/>
+                <a:ea typeface="+mn-ea"/>
+                <a:cs typeface="+mn-cs"/>
+              </a:rPr>
+              <a:t>OpenAI text-to-speech</a:t>
+            </a:r>
+            <a:r>
+              <a:rPr lang="en-US" sz="1200" b="0" i="0" kern="1200" dirty="0">
+                <a:solidFill>
+                  <a:schemeClr val="tx1"/>
+                </a:solidFill>
+                <a:effectLst/>
+                <a:latin typeface="+mn-lt"/>
+                <a:ea typeface="+mn-ea"/>
+                <a:cs typeface="+mn-cs"/>
+              </a:rPr>
+              <a:t> reads that script back as audio."</a:t>
+            </a:r>
+          </a:p>
+          <a:p>
+            <a:endParaRPr lang="en-US" sz="1200" b="0" i="0" kern="1200" dirty="0">
+              <a:solidFill>
+                <a:schemeClr val="tx1"/>
+              </a:solidFill>
+              <a:effectLst/>
+              <a:latin typeface="+mn-lt"/>
+              <a:ea typeface="+mn-ea"/>
+              <a:cs typeface="+mn-cs"/>
+            </a:endParaRPr>
+          </a:p>
+          <a:p>
+            <a:r>
+              <a:rPr lang="en-US" sz="1200" b="0" i="0" kern="1200" dirty="0">
+                <a:solidFill>
+                  <a:schemeClr val="tx1"/>
+                </a:solidFill>
+                <a:effectLst/>
+                <a:latin typeface="+mn-lt"/>
+                <a:ea typeface="+mn-ea"/>
+                <a:cs typeface="+mn-cs"/>
+              </a:rPr>
+              <a:t>Show the three outputs: </a:t>
+            </a:r>
+            <a:r>
+              <a:rPr lang="en-US" sz="1200" b="1" i="0" kern="1200" dirty="0">
+                <a:solidFill>
+                  <a:schemeClr val="tx1"/>
+                </a:solidFill>
+                <a:effectLst/>
+                <a:latin typeface="+mn-lt"/>
+                <a:ea typeface="+mn-ea"/>
+                <a:cs typeface="+mn-cs"/>
+              </a:rPr>
+              <a:t>Episode title → Key points → Recap script</a:t>
+            </a:r>
+            <a:r>
+              <a:rPr lang="en-US" sz="1200" b="0" i="0" kern="1200" dirty="0">
+                <a:solidFill>
+                  <a:schemeClr val="tx1"/>
+                </a:solidFill>
+                <a:effectLst/>
+                <a:latin typeface="+mn-lt"/>
+                <a:ea typeface="+mn-ea"/>
+                <a:cs typeface="+mn-cs"/>
+              </a:rPr>
+              <a:t>.</a:t>
+            </a:r>
+          </a:p>
+          <a:p>
+            <a:endParaRPr lang="en-US" sz="1200" b="1" i="0" kern="1200" dirty="0">
+              <a:solidFill>
+                <a:schemeClr val="tx1"/>
+              </a:solidFill>
+              <a:effectLst/>
+              <a:latin typeface="+mn-lt"/>
+              <a:ea typeface="+mn-ea"/>
+              <a:cs typeface="+mn-cs"/>
+            </a:endParaRPr>
+          </a:p>
+          <a:p>
+            <a:r>
+              <a:rPr lang="en-US" sz="1200" b="1" i="0" kern="1200" dirty="0">
+                <a:solidFill>
+                  <a:schemeClr val="tx1"/>
+                </a:solidFill>
+                <a:effectLst/>
+                <a:latin typeface="+mn-lt"/>
+                <a:ea typeface="+mn-ea"/>
+                <a:cs typeface="+mn-cs"/>
+              </a:rPr>
+              <a:t>Play the audio.</a:t>
+            </a:r>
+            <a:r>
+              <a:rPr lang="en-US" sz="1200" b="0" i="0" kern="1200" dirty="0">
+                <a:solidFill>
+                  <a:schemeClr val="tx1"/>
+                </a:solidFill>
+                <a:effectLst/>
+                <a:latin typeface="+mn-lt"/>
+                <a:ea typeface="+mn-ea"/>
+                <a:cs typeface="+mn-cs"/>
+              </a:rPr>
+              <a:t> Let a few seconds of it actually play — that's the wow moment.</a:t>
+            </a:r>
+          </a:p>
+          <a:p>
+            <a:endParaRPr lang="en-US" sz="1200" b="0" i="0" kern="1200" dirty="0">
+              <a:solidFill>
+                <a:schemeClr val="tx1"/>
+              </a:solidFill>
+              <a:effectLst/>
+              <a:latin typeface="+mn-lt"/>
+              <a:ea typeface="+mn-ea"/>
+              <a:cs typeface="+mn-cs"/>
+            </a:endParaRPr>
+          </a:p>
+          <a:p>
+            <a:r>
+              <a:rPr lang="en-US" sz="1200" b="0" i="0" kern="1200" dirty="0">
+                <a:solidFill>
+                  <a:schemeClr val="tx1"/>
+                </a:solidFill>
+                <a:effectLst/>
+                <a:latin typeface="+mn-lt"/>
+                <a:ea typeface="+mn-ea"/>
+                <a:cs typeface="+mn-cs"/>
+              </a:rPr>
+              <a:t>Quick flexibility mention (~10s, keep it verbal — stay on the reliable saved-lesson path, no live fetch): </a:t>
+            </a:r>
+          </a:p>
+          <a:p>
+            <a:endParaRPr lang="en-US" sz="1200" b="0" i="0" kern="1200" dirty="0">
+              <a:solidFill>
+                <a:schemeClr val="tx1"/>
+              </a:solidFill>
+              <a:effectLst/>
+              <a:latin typeface="+mn-lt"/>
+              <a:ea typeface="+mn-ea"/>
+              <a:cs typeface="+mn-cs"/>
+            </a:endParaRPr>
+          </a:p>
+          <a:p>
+            <a:r>
+              <a:rPr lang="en-US" sz="1200" b="0" i="0" kern="1200" dirty="0">
+                <a:solidFill>
+                  <a:schemeClr val="tx1"/>
+                </a:solidFill>
+                <a:effectLst/>
+                <a:latin typeface="+mn-lt"/>
+                <a:ea typeface="+mn-ea"/>
+                <a:cs typeface="+mn-cs"/>
+              </a:rPr>
+              <a:t>"It also takes a </a:t>
+            </a:r>
+            <a:r>
+              <a:rPr lang="en-US" sz="1200" b="1" i="0" kern="1200" dirty="0">
+                <a:solidFill>
+                  <a:schemeClr val="tx1"/>
+                </a:solidFill>
+                <a:effectLst/>
+                <a:latin typeface="+mn-lt"/>
+                <a:ea typeface="+mn-ea"/>
+                <a:cs typeface="+mn-cs"/>
+              </a:rPr>
+              <a:t>public URL</a:t>
+            </a:r>
+            <a:r>
+              <a:rPr lang="en-US" sz="1200" b="0" i="0" kern="1200" dirty="0">
+                <a:solidFill>
+                  <a:schemeClr val="tx1"/>
+                </a:solidFill>
+                <a:effectLst/>
+                <a:latin typeface="+mn-lt"/>
+                <a:ea typeface="+mn-ea"/>
+                <a:cs typeface="+mn-cs"/>
+              </a:rPr>
+              <a:t> or an </a:t>
+            </a:r>
+            <a:r>
+              <a:rPr lang="en-US" sz="1200" b="1" i="0" kern="1200" dirty="0">
+                <a:solidFill>
+                  <a:schemeClr val="tx1"/>
+                </a:solidFill>
+                <a:effectLst/>
+                <a:latin typeface="+mn-lt"/>
+                <a:ea typeface="+mn-ea"/>
+                <a:cs typeface="+mn-cs"/>
+              </a:rPr>
+              <a:t>uploaded file</a:t>
+            </a:r>
+            <a:r>
+              <a:rPr lang="en-US" sz="1200" b="0" i="0" kern="1200" dirty="0">
+                <a:solidFill>
+                  <a:schemeClr val="tx1"/>
+                </a:solidFill>
+                <a:effectLst/>
+                <a:latin typeface="+mn-lt"/>
+                <a:ea typeface="+mn-ea"/>
+                <a:cs typeface="+mn-cs"/>
+              </a:rPr>
+              <a:t> (.txt, .md, .pdf), so it works for lessons, articles, or your own notes too."</a:t>
+            </a:r>
+          </a:p>
+          <a:p>
+            <a:endParaRPr lang="en-US" sz="1200" b="0" i="0" kern="1200" dirty="0">
+              <a:solidFill>
+                <a:schemeClr val="tx1"/>
+              </a:solidFill>
+              <a:effectLst/>
+              <a:latin typeface="+mn-lt"/>
+              <a:ea typeface="+mn-ea"/>
+              <a:cs typeface="+mn-cs"/>
+            </a:endParaRPr>
+          </a:p>
+          <a:p>
+            <a:r>
+              <a:rPr lang="en-US" sz="1200" b="0" i="0" kern="1200" dirty="0">
+                <a:solidFill>
+                  <a:schemeClr val="tx1"/>
+                </a:solidFill>
+                <a:effectLst/>
+                <a:latin typeface="+mn-lt"/>
+                <a:ea typeface="+mn-ea"/>
+                <a:cs typeface="+mn-cs"/>
+              </a:rPr>
+              <a:t>Hand off: </a:t>
+            </a:r>
+            <a:r>
+              <a:rPr lang="en-US" sz="1200" b="0" i="1" kern="1200" dirty="0">
+                <a:solidFill>
+                  <a:schemeClr val="tx1"/>
+                </a:solidFill>
+                <a:effectLst/>
+                <a:latin typeface="+mn-lt"/>
+                <a:ea typeface="+mn-ea"/>
+                <a:cs typeface="+mn-cs"/>
+              </a:rPr>
+              <a:t>"Anand will cover what we learned and where we'd take it."</a:t>
+            </a:r>
+            <a:endParaRPr lang="en-US" sz="1200" b="0" i="0" kern="1200" dirty="0">
+              <a:solidFill>
+                <a:schemeClr val="tx1"/>
+              </a:solidFill>
+              <a:effectLst/>
+              <a:latin typeface="+mn-lt"/>
+              <a:ea typeface="+mn-ea"/>
+              <a:cs typeface="+mn-cs"/>
+            </a:endParaRPr>
+          </a:p>
+          <a:p>
+            <a:endParaRPr lang="en-US" sz="1200" b="1" i="0" kern="1200" dirty="0">
+              <a:solidFill>
+                <a:schemeClr val="tx1"/>
+              </a:solidFill>
+              <a:effectLst/>
+              <a:latin typeface="+mn-lt"/>
+              <a:ea typeface="+mn-ea"/>
+              <a:cs typeface="+mn-cs"/>
+            </a:endParaRPr>
+          </a:p>
+          <a:p>
+            <a:r>
+              <a:rPr lang="en-US" sz="1200" b="1" i="0" kern="1200" dirty="0">
+                <a:solidFill>
+                  <a:schemeClr val="tx1"/>
+                </a:solidFill>
+                <a:effectLst/>
+                <a:latin typeface="+mn-lt"/>
+                <a:ea typeface="+mn-ea"/>
+                <a:cs typeface="+mn-cs"/>
+              </a:rPr>
+              <a:t>If the live run stalls (Wi-Fi/API):</a:t>
+            </a:r>
+            <a:r>
+              <a:rPr lang="en-US" sz="1200" b="0" i="0" kern="1200" dirty="0">
+                <a:solidFill>
+                  <a:schemeClr val="tx1"/>
+                </a:solidFill>
+                <a:effectLst/>
+                <a:latin typeface="+mn-lt"/>
+                <a:ea typeface="+mn-ea"/>
+                <a:cs typeface="+mn-cs"/>
+              </a:rPr>
+              <a:t> immediately </a:t>
+            </a:r>
+            <a:r>
+              <a:rPr lang="en-US" sz="1200" b="1" i="0" kern="1200" dirty="0">
+                <a:solidFill>
+                  <a:schemeClr val="tx1"/>
+                </a:solidFill>
+                <a:effectLst/>
+                <a:latin typeface="+mn-lt"/>
+                <a:ea typeface="+mn-ea"/>
+                <a:cs typeface="+mn-cs"/>
+              </a:rPr>
+              <a:t>play a pre-generated </a:t>
+            </a:r>
+            <a:r>
+              <a:rPr lang="en-US" sz="1020" b="1" i="0" kern="1200" dirty="0">
+                <a:solidFill>
+                  <a:schemeClr val="tx1"/>
+                </a:solidFill>
+                <a:effectLst/>
+                <a:latin typeface="+mn-lt"/>
+                <a:ea typeface="+mn-ea"/>
+                <a:cs typeface="+mn-cs"/>
+              </a:rPr>
+              <a:t>.mp3</a:t>
+            </a:r>
+            <a:r>
+              <a:rPr lang="en-US" sz="1200" b="1" i="0" kern="1200" dirty="0">
+                <a:solidFill>
+                  <a:schemeClr val="tx1"/>
+                </a:solidFill>
+                <a:effectLst/>
+                <a:latin typeface="+mn-lt"/>
+                <a:ea typeface="+mn-ea"/>
+                <a:cs typeface="+mn-cs"/>
+              </a:rPr>
+              <a:t> from </a:t>
+            </a:r>
+            <a:r>
+              <a:rPr lang="en-US" sz="1020" b="1" i="0" kern="1200" dirty="0">
+                <a:solidFill>
+                  <a:schemeClr val="tx1"/>
+                </a:solidFill>
+                <a:effectLst/>
+                <a:latin typeface="+mn-lt"/>
+                <a:ea typeface="+mn-ea"/>
+                <a:cs typeface="+mn-cs"/>
+              </a:rPr>
+              <a:t>output/</a:t>
+            </a:r>
+            <a:r>
+              <a:rPr lang="en-US" sz="1200" b="0" i="0" kern="1200" dirty="0">
+                <a:solidFill>
+                  <a:schemeClr val="tx1"/>
+                </a:solidFill>
+                <a:effectLst/>
+                <a:latin typeface="+mn-lt"/>
+                <a:ea typeface="+mn-ea"/>
+                <a:cs typeface="+mn-cs"/>
+              </a:rPr>
+              <a:t> and keep narrating. Never stare at a spinner.</a:t>
+            </a:r>
+          </a:p>
+          <a:p>
+            <a:r>
+              <a:rPr lang="en-US" sz="1200" b="0" i="0" kern="1200" dirty="0">
+                <a:solidFill>
+                  <a:schemeClr val="tx1"/>
+                </a:solidFill>
+                <a:effectLst/>
+                <a:latin typeface="+mn-lt"/>
+                <a:ea typeface="+mn-ea"/>
+                <a:cs typeface="+mn-cs"/>
+              </a:rPr>
+              <a:t>Note: keep the demo on </a:t>
+            </a:r>
+            <a:r>
+              <a:rPr lang="en-US" sz="1200" b="1" i="0" kern="1200" dirty="0">
+                <a:solidFill>
+                  <a:schemeClr val="tx1"/>
+                </a:solidFill>
+                <a:effectLst/>
+                <a:latin typeface="+mn-lt"/>
+                <a:ea typeface="+mn-ea"/>
+                <a:cs typeface="+mn-cs"/>
+              </a:rPr>
+              <a:t>pick-a-saved-lesson</a:t>
+            </a:r>
+            <a:r>
+              <a:rPr lang="en-US" sz="1200" b="0" i="0" kern="1200" dirty="0">
+                <a:solidFill>
+                  <a:schemeClr val="tx1"/>
+                </a:solidFill>
+                <a:effectLst/>
+                <a:latin typeface="+mn-lt"/>
+                <a:ea typeface="+mn-ea"/>
+                <a:cs typeface="+mn-cs"/>
+              </a:rPr>
+              <a:t> — it's fast and reliable. We're not featuring the login-only-pages caveat; no need to raise it.</a:t>
             </a:r>
           </a:p>
         </p:txBody>

</xml_diff>

<commit_message>
Deck: add speaker notes for slides 1-2 (Adam — Intro + Problem)
Slides 3-5 had full spoken-script notes; 1, 2 and 6 still carried the old one-line
stubs. Fill in 1 and 2 from PRESENTATION.md verbatim (team intro, the one-line what-
it-is, the four problem beats, and the hand-off to Ugo), matching the stage-direction
+ quoted-line style used on 3-5.
Edited notesSlide1/2.xml in place — every other part is byte-identical, so the
teammates' slide and notes work is untouched. Verified: renders 6 slides, notes parse.
</commit_message>
<xml_diff>
--- a/Podcast-Studio-Presentation.pptx
+++ b/Podcast-Studio-Presentation.pptx
@@ -288,7 +288,25 @@
           <a:p>
             <a:r>
               <a:rPr lang="en-US" dirty="0"/>
-              <a:t>Title. SPEAKER 1 opens: name the team and what we built in one line.</a:t>
+              <a:t>Adam — Introduction (~45s). Open, name the team, one line on what it is — then straight into the problem.</a:t>
+            </a:r>
+          </a:p>
+          <a:p>
+            <a:r>
+              <a:rPr lang="en-US" dirty="0"/>
+              <a:t>“Hi, we’re Adam, Ugo, and Anand. We built Podcast Studio — a Content Recapper.”</a:t>
+            </a:r>
+          </a:p>
+          <a:p>
+            <a:r>
+              <a:rPr lang="en-US" dirty="0"/>
+              <a:t>What it is, in one line: “You give it a lesson — pick a saved one, a public URL, or upload a file — and it turns it into a short spoken recap podcast.”</a:t>
+            </a:r>
+          </a:p>
+          <a:p>
+            <a:r>
+              <a:rPr lang="en-US" dirty="0"/>
+              <a:t>Keep it to two sentences; the problem slide is where the story lands.</a:t>
             </a:r>
           </a:p>
         </p:txBody>
@@ -375,7 +393,37 @@
           <a:p>
             <a:r>
               <a:rPr lang="en-US" dirty="0"/>
-              <a:t>SPEAKER 1 — Problem. Anchor it in a real audience; hand off to SPEAKER 2 for the live demo.</a:t>
+              <a:t>Adam — Problem (~1:15). Anchor it in a real audience, then hand to Ugo.</a:t>
+            </a:r>
+          </a:p>
+          <a:p>
+            <a:r>
+              <a:rPr lang="en-US" dirty="0"/>
+              <a:t>“As students, we get hours of dense material every day and very little time to review it.”</a:t>
+            </a:r>
+          </a:p>
+          <a:p>
+            <a:r>
+              <a:rPr lang="en-US" dirty="0"/>
+              <a:t>“Reading notes back is slow. Listening isn’t — you can do it on the commute, at the gym, cooking.”</a:t>
+            </a:r>
+          </a:p>
+          <a:p>
+            <a:r>
+              <a:rPr lang="en-US" dirty="0"/>
+              <a:t>“So our audience is learners who want a ~1-minute audio recap to review on the go. It’s also an accessibility win for anyone who learns better by ear.”</a:t>
+            </a:r>
+          </a:p>
+          <a:p>
+            <a:r>
+              <a:rPr lang="en-US" dirty="0"/>
+              <a:t>“Think NotebookLM, but focused on your own lessons.”</a:t>
+            </a:r>
+          </a:p>
+          <a:p>
+            <a:r>
+              <a:rPr lang="en-US" dirty="0"/>
+              <a:t>Hand off: “Ugo will show it live.”</a:t>
             </a:r>
           </a:p>
         </p:txBody>

</xml_diff>

<commit_message>
Deck: add speaker notes for slide 6 (Q&A split)
Replace the last stub with the real Q&A split from PRESENTATION.md: the closing line
plus each question mapped to its owner (Adam: audience/team-can-run-it; Ugo: demo and
cost; Anand: grounding and why-OpenAI). Matches the style on slides 1-5.
Edited notesSlide6.xml in place — every other part byte-identical. Renders 6 slides.
</commit_message>
<xml_diff>
--- a/Podcast-Studio-Presentation.pptx
+++ b/Podcast-Studio-Presentation.pptx
@@ -2012,7 +2012,49 @@
           <a:p>
             <a:r>
               <a:rPr lang="en-US" dirty="0"/>
-              <a:t>All three field Q&amp;A. SPEAKER 1: audience/use. SPEAKER 2: demo/product/cost. SPEAKER 3: technical.</a:t>
+              <a:t>All three field Q&amp;A (~3 min) — split domains so nobody freezes. Closing line first:</a:t>
+            </a:r>
+          </a:p>
+          <a:p>
+            <a:r>
+              <a:rPr lang="en-US" dirty="0"/>
+              <a:t>“That’s the build — happy to take questions.”</a:t>
+            </a:r>
+          </a:p>
+          <a:p>
+            <a:r>
+              <a:rPr lang="en-US" dirty="0"/>
+              <a:t>Adam — “Who would actually use this?”: students reviewing on the go; accessibility; onboarding/training recaps.</a:t>
+            </a:r>
+          </a:p>
+          <a:p>
+            <a:r>
+              <a:rPr lang="en-US" dirty="0"/>
+              <a:t>Adam — “Could your team run it?”: yes — README + TEAM_GUIDE + double-click launchers, Mac &amp; Windows.</a:t>
+            </a:r>
+          </a:p>
+          <a:p>
+            <a:r>
+              <a:rPr lang="en-US" dirty="0"/>
+              <a:t>Ugo — demo/product (“can it do X?”): show or describe; scope is one lesson → one recap, extensible.</a:t>
+            </a:r>
+          </a:p>
+          <a:p>
+            <a:r>
+              <a:rPr lang="en-US" dirty="0"/>
+              <a:t>Ugo — cost: about 1 cent per recap (one LLM call + one TTS call).</a:t>
+            </a:r>
+          </a:p>
+          <a:p>
+            <a:r>
+              <a:rPr lang="en-US" dirty="0"/>
+              <a:t>Anand — “How do you stop it making things up?”: structured output + the prompt grounds it in the provided text.</a:t>
+            </a:r>
+          </a:p>
+          <a:p>
+            <a:r>
+              <a:rPr lang="en-US" dirty="0"/>
+              <a:t>Anand — “Why OpenAI for both?”: one key and bill, strong integration, TTS returns mp3 (no extra tools).</a:t>
             </a:r>
           </a:p>
         </p:txBody>

</xml_diff>